<commit_message>
feat: verificar Ubuntu local y actualizar evidencias de Practica 1
</commit_message>
<xml_diff>
--- a/entregables/Savia_IoT_Practica_1_AWS.pptx
+++ b/entregables/Savia_IoT_Practica_1_AWS.pptx
@@ -2,20 +2,20 @@
 <file path=ppt/presentation.xml><?xml version="1.0" encoding="utf-8"?>
 <p:presentation xmlns:p="http://schemas.openxmlformats.org/presentationml/2006/main">
   <p:sldMasterIdLst>
-    <p:sldMasterId xmlns:r="http://schemas.openxmlformats.org/officeDocument/2006/relationships" id="2147483648" r:id="R335ce2fcf11042d9"/>
+    <p:sldMasterId xmlns:r="http://schemas.openxmlformats.org/officeDocument/2006/relationships" id="2147483648" r:id="Refb1cb8a904e4d53"/>
   </p:sldMasterIdLst>
   <p:notesMasterIdLst>
-    <p:notesMasterId xmlns:r="http://schemas.openxmlformats.org/officeDocument/2006/relationships" r:id="Re0cdc4f5944b4f11"/>
+    <p:notesMasterId xmlns:r="http://schemas.openxmlformats.org/officeDocument/2006/relationships" r:id="Ree26e57669014280"/>
   </p:notesMasterIdLst>
   <p:sldIdLst>
-    <p:sldId xmlns:r="http://schemas.openxmlformats.org/officeDocument/2006/relationships" id="256" r:id="R8997c6699d1f47a4"/>
-    <p:sldId xmlns:r="http://schemas.openxmlformats.org/officeDocument/2006/relationships" id="257" r:id="Ra79527a840cf40b4"/>
-    <p:sldId xmlns:r="http://schemas.openxmlformats.org/officeDocument/2006/relationships" id="258" r:id="R0b8439fc0c814bfb"/>
-    <p:sldId xmlns:r="http://schemas.openxmlformats.org/officeDocument/2006/relationships" id="259" r:id="Rd7c17a986c80435b"/>
-    <p:sldId xmlns:r="http://schemas.openxmlformats.org/officeDocument/2006/relationships" id="260" r:id="R47a148acf9534b52"/>
-    <p:sldId xmlns:r="http://schemas.openxmlformats.org/officeDocument/2006/relationships" id="261" r:id="R19d1e2cbbba84a73"/>
-    <p:sldId xmlns:r="http://schemas.openxmlformats.org/officeDocument/2006/relationships" id="262" r:id="R7769e4c7accf434e"/>
-    <p:sldId xmlns:r="http://schemas.openxmlformats.org/officeDocument/2006/relationships" id="263" r:id="R28304724ba7640e1"/>
+    <p:sldId xmlns:r="http://schemas.openxmlformats.org/officeDocument/2006/relationships" id="256" r:id="R77be4f821c5f49cd"/>
+    <p:sldId xmlns:r="http://schemas.openxmlformats.org/officeDocument/2006/relationships" id="257" r:id="R099919d396bf45bd"/>
+    <p:sldId xmlns:r="http://schemas.openxmlformats.org/officeDocument/2006/relationships" id="258" r:id="R0817a31453c74467"/>
+    <p:sldId xmlns:r="http://schemas.openxmlformats.org/officeDocument/2006/relationships" id="259" r:id="Rb78e27a7d51f4eff"/>
+    <p:sldId xmlns:r="http://schemas.openxmlformats.org/officeDocument/2006/relationships" id="260" r:id="Rf491e991c6a6464e"/>
+    <p:sldId xmlns:r="http://schemas.openxmlformats.org/officeDocument/2006/relationships" id="261" r:id="Raf9c53b544974edf"/>
+    <p:sldId xmlns:r="http://schemas.openxmlformats.org/officeDocument/2006/relationships" id="262" r:id="R2a143e034ec54bd5"/>
+    <p:sldId xmlns:r="http://schemas.openxmlformats.org/officeDocument/2006/relationships" id="263" r:id="R4c78ff2e21934fde"/>
   </p:sldIdLst>
   <p:sldSz cx="12192000" cy="6858000"/>
   <p:notesSz cx="6858000" cy="9144000"/>
@@ -954,7 +954,7 @@
           <p:cNvPr id="3" name="Title">
             <a:extLst xmlns:a="http://schemas.openxmlformats.org/drawingml/2006/main">
               <a:ext uri="{FF2B5EF4-FFF2-40B4-BE49-F238E27FC236}">
-                <a16:creationId xmlns:a16="http://schemas.microsoft.com/office/drawing/2014/main" id="{C7B0E581-C18F-493E-8AAC-A26EE5B10F0F}"/>
+                <a16:creationId xmlns:a16="http://schemas.microsoft.com/office/drawing/2014/main" id="{BD973EED-8A5C-44EA-9424-E9DF30B3138D}"/>
               </a:ext>
             </a:extLst>
           </p:cNvPr>
@@ -1183,7 +1183,7 @@
           <p:cNvPr id="2" name="Subtitle">
             <a:extLst xmlns:a="http://schemas.openxmlformats.org/drawingml/2006/main">
               <a:ext uri="{FF2B5EF4-FFF2-40B4-BE49-F238E27FC236}">
-                <a16:creationId xmlns:a16="http://schemas.microsoft.com/office/drawing/2014/main" id="{46B9412D-9413-4158-90DD-19F3623F46E2}"/>
+                <a16:creationId xmlns:a16="http://schemas.microsoft.com/office/drawing/2014/main" id="{D7045DAA-766C-47C0-808C-57FCB96671DA}"/>
               </a:ext>
             </a:extLst>
           </p:cNvPr>
@@ -1429,7 +1429,7 @@
           <p:cNvPr id="2" name="Section title">
             <a:extLst xmlns:a="http://schemas.openxmlformats.org/drawingml/2006/main">
               <a:ext uri="{FF2B5EF4-FFF2-40B4-BE49-F238E27FC236}">
-                <a16:creationId xmlns:a16="http://schemas.microsoft.com/office/drawing/2014/main" id="{35FDF5FA-494B-4EDD-B363-54030A95CDBC}"/>
+                <a16:creationId xmlns:a16="http://schemas.microsoft.com/office/drawing/2014/main" id="{F7534D8A-B10C-4286-9CA6-0AB903BB12CB}"/>
               </a:ext>
             </a:extLst>
           </p:cNvPr>
@@ -1675,7 +1675,7 @@
           <p:cNvPr id="3" name="Title">
             <a:extLst xmlns:a="http://schemas.openxmlformats.org/drawingml/2006/main">
               <a:ext uri="{FF2B5EF4-FFF2-40B4-BE49-F238E27FC236}">
-                <a16:creationId xmlns:a16="http://schemas.microsoft.com/office/drawing/2014/main" id="{1C659CD8-8B38-46D9-9E1C-706180A1EF7A}"/>
+                <a16:creationId xmlns:a16="http://schemas.microsoft.com/office/drawing/2014/main" id="{3F748939-DDC7-4177-B9C8-25FD6883D27A}"/>
               </a:ext>
             </a:extLst>
           </p:cNvPr>
@@ -1904,7 +1904,7 @@
           <p:cNvPr id="2" name="Body">
             <a:extLst xmlns:a="http://schemas.openxmlformats.org/drawingml/2006/main">
               <a:ext uri="{FF2B5EF4-FFF2-40B4-BE49-F238E27FC236}">
-                <a16:creationId xmlns:a16="http://schemas.microsoft.com/office/drawing/2014/main" id="{4FDF95DD-0C6F-4765-9182-2EE5EBE9BFE9}"/>
+                <a16:creationId xmlns:a16="http://schemas.microsoft.com/office/drawing/2014/main" id="{94C3CF20-8432-4AD2-B005-83E1C2333230}"/>
               </a:ext>
             </a:extLst>
           </p:cNvPr>
@@ -2150,7 +2150,7 @@
           <p:cNvPr id="4" name="Title">
             <a:extLst xmlns:a="http://schemas.openxmlformats.org/drawingml/2006/main">
               <a:ext uri="{FF2B5EF4-FFF2-40B4-BE49-F238E27FC236}">
-                <a16:creationId xmlns:a16="http://schemas.microsoft.com/office/drawing/2014/main" id="{31575AF5-A887-4555-AB05-C77E1EE22472}"/>
+                <a16:creationId xmlns:a16="http://schemas.microsoft.com/office/drawing/2014/main" id="{CE444E2C-834E-4CDC-B798-D93DED2AA7F1}"/>
               </a:ext>
             </a:extLst>
           </p:cNvPr>
@@ -2379,7 +2379,7 @@
           <p:cNvPr id="2" name="Left column">
             <a:extLst xmlns:a="http://schemas.openxmlformats.org/drawingml/2006/main">
               <a:ext uri="{FF2B5EF4-FFF2-40B4-BE49-F238E27FC236}">
-                <a16:creationId xmlns:a16="http://schemas.microsoft.com/office/drawing/2014/main" id="{CC079CC1-8323-4A1B-AF5E-2E5B86BF3583}"/>
+                <a16:creationId xmlns:a16="http://schemas.microsoft.com/office/drawing/2014/main" id="{BD97FCA6-AE99-4630-8CA4-61B7DE07B3B6}"/>
               </a:ext>
             </a:extLst>
           </p:cNvPr>
@@ -2608,7 +2608,7 @@
           <p:cNvPr id="3" name="Right column">
             <a:extLst xmlns:a="http://schemas.openxmlformats.org/drawingml/2006/main">
               <a:ext uri="{FF2B5EF4-FFF2-40B4-BE49-F238E27FC236}">
-                <a16:creationId xmlns:a16="http://schemas.microsoft.com/office/drawing/2014/main" id="{BC04FC88-9650-47B9-92E9-A7EB5CC5E64E}"/>
+                <a16:creationId xmlns:a16="http://schemas.microsoft.com/office/drawing/2014/main" id="{17D2C47E-7FEB-49F3-98F0-1EA90C76BFE5}"/>
               </a:ext>
             </a:extLst>
           </p:cNvPr>
@@ -2854,7 +2854,7 @@
           <p:cNvPr id="3" name="Title">
             <a:extLst xmlns:a="http://schemas.openxmlformats.org/drawingml/2006/main">
               <a:ext uri="{FF2B5EF4-FFF2-40B4-BE49-F238E27FC236}">
-                <a16:creationId xmlns:a16="http://schemas.microsoft.com/office/drawing/2014/main" id="{8CB1E94F-935D-4F80-A00D-F7E2D8E4413B}"/>
+                <a16:creationId xmlns:a16="http://schemas.microsoft.com/office/drawing/2014/main" id="{AD1F0167-07C5-4D1F-9DBC-CE7057D57BB0}"/>
               </a:ext>
             </a:extLst>
           </p:cNvPr>
@@ -3083,7 +3083,7 @@
           <p:cNvPr id="2" name="Left column">
             <a:extLst xmlns:a="http://schemas.openxmlformats.org/drawingml/2006/main">
               <a:ext uri="{FF2B5EF4-FFF2-40B4-BE49-F238E27FC236}">
-                <a16:creationId xmlns:a16="http://schemas.microsoft.com/office/drawing/2014/main" id="{2A3C146B-8B6D-4227-81B0-C2B588631D90}"/>
+                <a16:creationId xmlns:a16="http://schemas.microsoft.com/office/drawing/2014/main" id="{9477C4BF-6BF6-4791-867E-C2CEE5F1F786}"/>
               </a:ext>
             </a:extLst>
           </p:cNvPr>
@@ -3350,12 +3350,12 @@
   </p:cSld>
   <p:clrMap bg1="lt1" tx1="dk1" bg2="lt2" tx2="dk2" accent1="accent1" accent2="accent2" accent3="accent3" accent4="accent4" accent5="accent5" accent6="accent6" hlink="hlink" folHlink="folHlink"/>
   <p:sldLayoutIdLst>
-    <p:sldLayoutId xmlns:r="http://schemas.openxmlformats.org/officeDocument/2006/relationships" id="2147483649" r:id="R503c1ea25c944bd6"/>
-    <p:sldLayoutId xmlns:r="http://schemas.openxmlformats.org/officeDocument/2006/relationships" id="2147483650" r:id="Re533f7d569c84ca9"/>
-    <p:sldLayoutId xmlns:r="http://schemas.openxmlformats.org/officeDocument/2006/relationships" id="2147483651" r:id="R7fae4323156241da"/>
-    <p:sldLayoutId xmlns:r="http://schemas.openxmlformats.org/officeDocument/2006/relationships" id="2147483652" r:id="R38368d80a807499f"/>
-    <p:sldLayoutId xmlns:r="http://schemas.openxmlformats.org/officeDocument/2006/relationships" id="2147483653" r:id="R2ff05c96092c4e6e"/>
-    <p:sldLayoutId xmlns:r="http://schemas.openxmlformats.org/officeDocument/2006/relationships" id="2147483654" r:id="R80e43b724c5e4b60"/>
+    <p:sldLayoutId xmlns:r="http://schemas.openxmlformats.org/officeDocument/2006/relationships" id="2147483649" r:id="R86af710a13db4414"/>
+    <p:sldLayoutId xmlns:r="http://schemas.openxmlformats.org/officeDocument/2006/relationships" id="2147483650" r:id="R1e7607d6e1cf44a2"/>
+    <p:sldLayoutId xmlns:r="http://schemas.openxmlformats.org/officeDocument/2006/relationships" id="2147483651" r:id="R7ba989c95e7f4579"/>
+    <p:sldLayoutId xmlns:r="http://schemas.openxmlformats.org/officeDocument/2006/relationships" id="2147483652" r:id="Rb99d78df2e7a4563"/>
+    <p:sldLayoutId xmlns:r="http://schemas.openxmlformats.org/officeDocument/2006/relationships" id="2147483653" r:id="R80228a1bd96b4a0c"/>
+    <p:sldLayoutId xmlns:r="http://schemas.openxmlformats.org/officeDocument/2006/relationships" id="2147483654" r:id="R37f2ef9af4a04701"/>
   </p:sldLayoutIdLst>
   <p:txStyles>
     <p:titleStyle>
@@ -3906,7 +3906,7 @@
           <p:cNvPr id="11" name="">
             <a:extLst xmlns:a="http://schemas.openxmlformats.org/drawingml/2006/main">
               <a:ext uri="{FF2B5EF4-FFF2-40B4-BE49-F238E27FC236}">
-                <a16:creationId xmlns:a16="http://schemas.microsoft.com/office/drawing/2014/main" id="{9F3A49CC-2B06-4894-8AAC-CAAC14400A0B}"/>
+                <a16:creationId xmlns:a16="http://schemas.microsoft.com/office/drawing/2014/main" id="{12116F49-CE00-4522-BF03-F5D57A8E7647}"/>
               </a:ext>
             </a:extLst>
           </p:cNvPr>
@@ -3937,7 +3937,7 @@
           <p:cNvPr id="2" name="">
             <a:extLst xmlns:a="http://schemas.openxmlformats.org/drawingml/2006/main">
               <a:ext uri="{FF2B5EF4-FFF2-40B4-BE49-F238E27FC236}">
-                <a16:creationId xmlns:a16="http://schemas.microsoft.com/office/drawing/2014/main" id="{6A3280AE-0E1D-416F-9453-0EAF0DEF6AEA}"/>
+                <a16:creationId xmlns:a16="http://schemas.microsoft.com/office/drawing/2014/main" id="{E607D2B8-126C-446A-83A8-65C7603CADD1}"/>
               </a:ext>
             </a:extLst>
           </p:cNvPr>
@@ -3947,7 +3947,7 @@
           <p:nvPr/>
         </p:nvPicPr>
         <p:blipFill>
-          <a:blip xmlns:r="http://schemas.openxmlformats.org/officeDocument/2006/relationships" xmlns:a="http://schemas.openxmlformats.org/drawingml/2006/main" r:embed="R8a149295d8f44250"/>
+          <a:blip xmlns:r="http://schemas.openxmlformats.org/officeDocument/2006/relationships" xmlns:a="http://schemas.openxmlformats.org/drawingml/2006/main" r:embed="R6096172deac746d9"/>
           <a:srcRect xmlns:a="http://schemas.openxmlformats.org/drawingml/2006/main" l="22685" t="0" r="22685" b="0"/>
           <a:stretch xmlns:a="http://schemas.openxmlformats.org/drawingml/2006/main">
             <a:fillRect l="0" t="0" r="0" b="0"/>
@@ -3968,7 +3968,7 @@
           <p:cNvPr id="3" name="">
             <a:extLst xmlns:a="http://schemas.openxmlformats.org/drawingml/2006/main">
               <a:ext uri="{FF2B5EF4-FFF2-40B4-BE49-F238E27FC236}">
-                <a16:creationId xmlns:a16="http://schemas.microsoft.com/office/drawing/2014/main" id="{752BAE41-87B4-4316-8210-B0280A1D38D9}"/>
+                <a16:creationId xmlns:a16="http://schemas.microsoft.com/office/drawing/2014/main" id="{D9577F8E-C18F-4DF3-A2EC-887FFB975E59}"/>
               </a:ext>
             </a:extLst>
           </p:cNvPr>
@@ -3978,7 +3978,7 @@
           <p:nvPr/>
         </p:nvPicPr>
         <p:blipFill>
-          <a:blip xmlns:r="http://schemas.openxmlformats.org/officeDocument/2006/relationships" xmlns:a="http://schemas.openxmlformats.org/drawingml/2006/main" r:embed="Rf05ed0de9e714d18"/>
+          <a:blip xmlns:r="http://schemas.openxmlformats.org/officeDocument/2006/relationships" xmlns:a="http://schemas.openxmlformats.org/drawingml/2006/main" r:embed="Rbbc70635f3104ee9"/>
           <a:stretch xmlns:a="http://schemas.openxmlformats.org/drawingml/2006/main"/>
         </p:blipFill>
         <p:spPr>
@@ -3996,7 +3996,7 @@
           <p:cNvPr id="4" name="">
             <a:extLst xmlns:a="http://schemas.openxmlformats.org/drawingml/2006/main">
               <a:ext uri="{FF2B5EF4-FFF2-40B4-BE49-F238E27FC236}">
-                <a16:creationId xmlns:a16="http://schemas.microsoft.com/office/drawing/2014/main" id="{35C92811-58DF-485E-BA92-7247AF1F3430}"/>
+                <a16:creationId xmlns:a16="http://schemas.microsoft.com/office/drawing/2014/main" id="{2F8E56BC-86E6-4C5E-9888-1019D84D2E31}"/>
               </a:ext>
             </a:extLst>
           </p:cNvPr>
@@ -4117,7 +4117,7 @@
           <p:cNvPr id="5" name="">
             <a:extLst xmlns:a="http://schemas.openxmlformats.org/drawingml/2006/main">
               <a:ext uri="{FF2B5EF4-FFF2-40B4-BE49-F238E27FC236}">
-                <a16:creationId xmlns:a16="http://schemas.microsoft.com/office/drawing/2014/main" id="{0DBAD15F-8735-4486-B1D4-9A14886DD731}"/>
+                <a16:creationId xmlns:a16="http://schemas.microsoft.com/office/drawing/2014/main" id="{4AF34958-A696-421B-9B15-6E08EB79B544}"/>
               </a:ext>
             </a:extLst>
           </p:cNvPr>
@@ -4238,7 +4238,7 @@
           <p:cNvPr id="6" name="">
             <a:extLst xmlns:a="http://schemas.openxmlformats.org/drawingml/2006/main">
               <a:ext uri="{FF2B5EF4-FFF2-40B4-BE49-F238E27FC236}">
-                <a16:creationId xmlns:a16="http://schemas.microsoft.com/office/drawing/2014/main" id="{5E76B693-9A3B-4E06-8060-7D3D26B8AD9E}"/>
+                <a16:creationId xmlns:a16="http://schemas.microsoft.com/office/drawing/2014/main" id="{2B884B12-3235-4CA7-8FF4-149126A0D44E}"/>
               </a:ext>
             </a:extLst>
           </p:cNvPr>
@@ -4269,7 +4269,7 @@
           <p:cNvPr id="7" name="">
             <a:extLst xmlns:a="http://schemas.openxmlformats.org/drawingml/2006/main">
               <a:ext uri="{FF2B5EF4-FFF2-40B4-BE49-F238E27FC236}">
-                <a16:creationId xmlns:a16="http://schemas.microsoft.com/office/drawing/2014/main" id="{C26CC41A-6352-448A-8319-52F2F8EAC6A1}"/>
+                <a16:creationId xmlns:a16="http://schemas.microsoft.com/office/drawing/2014/main" id="{F1186ECB-D5DC-43E7-90C8-0B70BE210CAC}"/>
               </a:ext>
             </a:extLst>
           </p:cNvPr>
@@ -4390,7 +4390,7 @@
           <p:cNvPr id="8" name="">
             <a:extLst xmlns:a="http://schemas.openxmlformats.org/drawingml/2006/main">
               <a:ext uri="{FF2B5EF4-FFF2-40B4-BE49-F238E27FC236}">
-                <a16:creationId xmlns:a16="http://schemas.microsoft.com/office/drawing/2014/main" id="{D5C40797-04C2-4080-8F17-4D588AEB8150}"/>
+                <a16:creationId xmlns:a16="http://schemas.microsoft.com/office/drawing/2014/main" id="{ACD36756-1F3D-4E7F-8722-C05825A7903C}"/>
               </a:ext>
             </a:extLst>
           </p:cNvPr>
@@ -4511,7 +4511,7 @@
           <p:cNvPr id="9" name="">
             <a:extLst xmlns:a="http://schemas.openxmlformats.org/drawingml/2006/main">
               <a:ext uri="{FF2B5EF4-FFF2-40B4-BE49-F238E27FC236}">
-                <a16:creationId xmlns:a16="http://schemas.microsoft.com/office/drawing/2014/main" id="{F2185BB2-4F54-4EB0-9A9B-107533DDB9DE}"/>
+                <a16:creationId xmlns:a16="http://schemas.microsoft.com/office/drawing/2014/main" id="{E13D4F25-0CCE-4C38-AF22-30F07E8A6A93}"/>
               </a:ext>
             </a:extLst>
           </p:cNvPr>
@@ -4649,7 +4649,7 @@
           <p:cNvPr id="10" name="">
             <a:extLst xmlns:a="http://schemas.openxmlformats.org/drawingml/2006/main">
               <a:ext uri="{FF2B5EF4-FFF2-40B4-BE49-F238E27FC236}">
-                <a16:creationId xmlns:a16="http://schemas.microsoft.com/office/drawing/2014/main" id="{EAF3CA0D-1A86-4DD8-BFB7-DF329AD93726}"/>
+                <a16:creationId xmlns:a16="http://schemas.microsoft.com/office/drawing/2014/main" id="{4C1DD028-1728-4D0F-9F59-EA1852843AB8}"/>
               </a:ext>
             </a:extLst>
           </p:cNvPr>
@@ -4768,7 +4768,7 @@
     </p:spTree>
     <p:extLst>
       <p:ext uri="{BB962C8B-B14F-4D97-AF65-F5344CB8AC3E}">
-        <p14:creationId xmlns:p14="http://schemas.microsoft.com/office/powerpoint/2010/main" val="1165654256"/>
+        <p14:creationId xmlns:p14="http://schemas.microsoft.com/office/powerpoint/2010/main" val="582873566"/>
       </p:ext>
     </p:extLst>
   </p:cSld>
@@ -4799,7 +4799,7 @@
           <p:cNvPr id="15" name="">
             <a:extLst xmlns:a="http://schemas.openxmlformats.org/drawingml/2006/main">
               <a:ext uri="{FF2B5EF4-FFF2-40B4-BE49-F238E27FC236}">
-                <a16:creationId xmlns:a16="http://schemas.microsoft.com/office/drawing/2014/main" id="{446F0068-4934-4A43-BF28-9B68929478AE}"/>
+                <a16:creationId xmlns:a16="http://schemas.microsoft.com/office/drawing/2014/main" id="{A3288B61-E5C3-4F19-B767-EFF3F1C997A5}"/>
               </a:ext>
             </a:extLst>
           </p:cNvPr>
@@ -4830,7 +4830,7 @@
           <p:cNvPr id="2" name="">
             <a:extLst xmlns:a="http://schemas.openxmlformats.org/drawingml/2006/main">
               <a:ext uri="{FF2B5EF4-FFF2-40B4-BE49-F238E27FC236}">
-                <a16:creationId xmlns:a16="http://schemas.microsoft.com/office/drawing/2014/main" id="{40FAB25E-2E94-48C8-A4F2-4C7215236898}"/>
+                <a16:creationId xmlns:a16="http://schemas.microsoft.com/office/drawing/2014/main" id="{FEB75594-D32B-47D5-BEE3-834DF5EE19D8}"/>
               </a:ext>
             </a:extLst>
           </p:cNvPr>
@@ -4951,7 +4951,7 @@
           <p:cNvPr id="3" name="">
             <a:extLst xmlns:a="http://schemas.openxmlformats.org/drawingml/2006/main">
               <a:ext uri="{FF2B5EF4-FFF2-40B4-BE49-F238E27FC236}">
-                <a16:creationId xmlns:a16="http://schemas.microsoft.com/office/drawing/2014/main" id="{A699B4DF-2DA2-4772-A338-934920C2678D}"/>
+                <a16:creationId xmlns:a16="http://schemas.microsoft.com/office/drawing/2014/main" id="{EB629AE8-4D2B-42AB-A9D3-2F63F72FD3A9}"/>
               </a:ext>
             </a:extLst>
           </p:cNvPr>
@@ -5072,7 +5072,7 @@
           <p:cNvPr id="4" name="">
             <a:extLst xmlns:a="http://schemas.openxmlformats.org/drawingml/2006/main">
               <a:ext uri="{FF2B5EF4-FFF2-40B4-BE49-F238E27FC236}">
-                <a16:creationId xmlns:a16="http://schemas.microsoft.com/office/drawing/2014/main" id="{C03A7576-A2BF-4F3F-8BDD-42B4BF67B6F9}"/>
+                <a16:creationId xmlns:a16="http://schemas.microsoft.com/office/drawing/2014/main" id="{5A060A6C-2598-487F-B5DA-4BCA1E0E0750}"/>
               </a:ext>
             </a:extLst>
           </p:cNvPr>
@@ -5193,7 +5193,7 @@
           <p:cNvPr id="5" name="">
             <a:extLst xmlns:a="http://schemas.openxmlformats.org/drawingml/2006/main">
               <a:ext uri="{FF2B5EF4-FFF2-40B4-BE49-F238E27FC236}">
-                <a16:creationId xmlns:a16="http://schemas.microsoft.com/office/drawing/2014/main" id="{2D5F45D5-75D1-453A-A2FE-1E20AD667912}"/>
+                <a16:creationId xmlns:a16="http://schemas.microsoft.com/office/drawing/2014/main" id="{15DB4689-2950-481A-BB87-4B604032BEE6}"/>
               </a:ext>
             </a:extLst>
           </p:cNvPr>
@@ -5314,7 +5314,7 @@
           <p:cNvPr id="6" name="">
             <a:extLst xmlns:a="http://schemas.openxmlformats.org/drawingml/2006/main">
               <a:ext uri="{FF2B5EF4-FFF2-40B4-BE49-F238E27FC236}">
-                <a16:creationId xmlns:a16="http://schemas.microsoft.com/office/drawing/2014/main" id="{7E6CD808-3274-4F0E-991A-8A840BBFEFEB}"/>
+                <a16:creationId xmlns:a16="http://schemas.microsoft.com/office/drawing/2014/main" id="{5A580411-3850-4CA9-A9E2-2DCF060321BA}"/>
               </a:ext>
             </a:extLst>
           </p:cNvPr>
@@ -5345,7 +5345,7 @@
           <p:cNvPr id="7" name="">
             <a:extLst xmlns:a="http://schemas.openxmlformats.org/drawingml/2006/main">
               <a:ext uri="{FF2B5EF4-FFF2-40B4-BE49-F238E27FC236}">
-                <a16:creationId xmlns:a16="http://schemas.microsoft.com/office/drawing/2014/main" id="{244351DA-EB0A-41A7-A3AA-EA7263B83A26}"/>
+                <a16:creationId xmlns:a16="http://schemas.microsoft.com/office/drawing/2014/main" id="{87EF6DEE-A95A-4573-A9FA-8098B5C0CE15}"/>
               </a:ext>
             </a:extLst>
           </p:cNvPr>
@@ -5466,7 +5466,7 @@
           <p:cNvPr id="8" name="">
             <a:extLst xmlns:a="http://schemas.openxmlformats.org/drawingml/2006/main">
               <a:ext uri="{FF2B5EF4-FFF2-40B4-BE49-F238E27FC236}">
-                <a16:creationId xmlns:a16="http://schemas.microsoft.com/office/drawing/2014/main" id="{C795AF86-6364-4B77-9D1B-BA869B6FD5F0}"/>
+                <a16:creationId xmlns:a16="http://schemas.microsoft.com/office/drawing/2014/main" id="{CD65E1F6-A8EF-4C12-927B-7FFA57D9A14A}"/>
               </a:ext>
             </a:extLst>
           </p:cNvPr>
@@ -5587,7 +5587,7 @@
           <p:cNvPr id="9" name="">
             <a:extLst xmlns:a="http://schemas.openxmlformats.org/drawingml/2006/main">
               <a:ext uri="{FF2B5EF4-FFF2-40B4-BE49-F238E27FC236}">
-                <a16:creationId xmlns:a16="http://schemas.microsoft.com/office/drawing/2014/main" id="{21D735E6-A550-4AA3-A109-44D5BC1A5E92}"/>
+                <a16:creationId xmlns:a16="http://schemas.microsoft.com/office/drawing/2014/main" id="{D7D4F99B-3EA0-4E84-9C84-0F6E6386D105}"/>
               </a:ext>
             </a:extLst>
           </p:cNvPr>
@@ -5618,7 +5618,7 @@
           <p:cNvPr id="10" name="">
             <a:extLst xmlns:a="http://schemas.openxmlformats.org/drawingml/2006/main">
               <a:ext uri="{FF2B5EF4-FFF2-40B4-BE49-F238E27FC236}">
-                <a16:creationId xmlns:a16="http://schemas.microsoft.com/office/drawing/2014/main" id="{B8B666A7-FFEB-494C-8041-04C3A6FF7122}"/>
+                <a16:creationId xmlns:a16="http://schemas.microsoft.com/office/drawing/2014/main" id="{8F778D75-86F7-45A8-BD0E-860C5AE6A121}"/>
               </a:ext>
             </a:extLst>
           </p:cNvPr>
@@ -5739,7 +5739,7 @@
           <p:cNvPr id="11" name="">
             <a:extLst xmlns:a="http://schemas.openxmlformats.org/drawingml/2006/main">
               <a:ext uri="{FF2B5EF4-FFF2-40B4-BE49-F238E27FC236}">
-                <a16:creationId xmlns:a16="http://schemas.microsoft.com/office/drawing/2014/main" id="{106DB61C-82E7-4152-8D60-0AAF55FF99E1}"/>
+                <a16:creationId xmlns:a16="http://schemas.microsoft.com/office/drawing/2014/main" id="{1C964C08-4F44-42C5-9710-6A261B731075}"/>
               </a:ext>
             </a:extLst>
           </p:cNvPr>
@@ -5860,7 +5860,7 @@
           <p:cNvPr id="12" name="">
             <a:extLst xmlns:a="http://schemas.openxmlformats.org/drawingml/2006/main">
               <a:ext uri="{FF2B5EF4-FFF2-40B4-BE49-F238E27FC236}">
-                <a16:creationId xmlns:a16="http://schemas.microsoft.com/office/drawing/2014/main" id="{4DDB4040-F94A-410E-B1CA-68F0C0D691A8}"/>
+                <a16:creationId xmlns:a16="http://schemas.microsoft.com/office/drawing/2014/main" id="{B3C4C8F7-0627-43AF-BEB2-A925CBE12347}"/>
               </a:ext>
             </a:extLst>
           </p:cNvPr>
@@ -5891,7 +5891,7 @@
           <p:cNvPr id="13" name="">
             <a:extLst xmlns:a="http://schemas.openxmlformats.org/drawingml/2006/main">
               <a:ext uri="{FF2B5EF4-FFF2-40B4-BE49-F238E27FC236}">
-                <a16:creationId xmlns:a16="http://schemas.microsoft.com/office/drawing/2014/main" id="{09502819-B47A-441C-8D3A-D4099E29A04D}"/>
+                <a16:creationId xmlns:a16="http://schemas.microsoft.com/office/drawing/2014/main" id="{30C297BE-2728-4E31-AC42-0E338DA6C10D}"/>
               </a:ext>
             </a:extLst>
           </p:cNvPr>
@@ -6012,7 +6012,7 @@
           <p:cNvPr id="14" name="">
             <a:extLst xmlns:a="http://schemas.openxmlformats.org/drawingml/2006/main">
               <a:ext uri="{FF2B5EF4-FFF2-40B4-BE49-F238E27FC236}">
-                <a16:creationId xmlns:a16="http://schemas.microsoft.com/office/drawing/2014/main" id="{496428C8-63F3-48D0-9E2A-3D2FD92E52C6}"/>
+                <a16:creationId xmlns:a16="http://schemas.microsoft.com/office/drawing/2014/main" id="{46129D21-152B-4A59-95C9-DC2B128BD4A3}"/>
               </a:ext>
             </a:extLst>
           </p:cNvPr>
@@ -6131,7 +6131,7 @@
     </p:spTree>
     <p:extLst>
       <p:ext uri="{BB962C8B-B14F-4D97-AF65-F5344CB8AC3E}">
-        <p14:creationId xmlns:p14="http://schemas.microsoft.com/office/powerpoint/2010/main" val="396999997"/>
+        <p14:creationId xmlns:p14="http://schemas.microsoft.com/office/powerpoint/2010/main" val="1646010462"/>
       </p:ext>
     </p:extLst>
   </p:cSld>
@@ -6162,7 +6162,7 @@
           <p:cNvPr id="11" name="">
             <a:extLst xmlns:a="http://schemas.openxmlformats.org/drawingml/2006/main">
               <a:ext uri="{FF2B5EF4-FFF2-40B4-BE49-F238E27FC236}">
-                <a16:creationId xmlns:a16="http://schemas.microsoft.com/office/drawing/2014/main" id="{F996AD6F-22B4-4599-8F5F-15AE30FC9D1E}"/>
+                <a16:creationId xmlns:a16="http://schemas.microsoft.com/office/drawing/2014/main" id="{E519CB4D-7447-469B-9352-621A21D037DC}"/>
               </a:ext>
             </a:extLst>
           </p:cNvPr>
@@ -6193,7 +6193,7 @@
           <p:cNvPr id="2" name="">
             <a:extLst xmlns:a="http://schemas.openxmlformats.org/drawingml/2006/main">
               <a:ext uri="{FF2B5EF4-FFF2-40B4-BE49-F238E27FC236}">
-                <a16:creationId xmlns:a16="http://schemas.microsoft.com/office/drawing/2014/main" id="{5DB0D002-E8EE-49A4-B5C1-A9DCA6970200}"/>
+                <a16:creationId xmlns:a16="http://schemas.microsoft.com/office/drawing/2014/main" id="{24F24A05-02CA-4F7E-B28F-AD02D28F8CAB}"/>
               </a:ext>
             </a:extLst>
           </p:cNvPr>
@@ -6314,7 +6314,7 @@
           <p:cNvPr id="3" name="">
             <a:extLst xmlns:a="http://schemas.openxmlformats.org/drawingml/2006/main">
               <a:ext uri="{FF2B5EF4-FFF2-40B4-BE49-F238E27FC236}">
-                <a16:creationId xmlns:a16="http://schemas.microsoft.com/office/drawing/2014/main" id="{F5B85996-022D-4BFD-BBAD-70E5256B83ED}"/>
+                <a16:creationId xmlns:a16="http://schemas.microsoft.com/office/drawing/2014/main" id="{A524A237-9CCE-45EB-883F-9E5E8803DDA4}"/>
               </a:ext>
             </a:extLst>
           </p:cNvPr>
@@ -6435,7 +6435,7 @@
           <p:cNvPr id="4" name="">
             <a:extLst xmlns:a="http://schemas.openxmlformats.org/drawingml/2006/main">
               <a:ext uri="{FF2B5EF4-FFF2-40B4-BE49-F238E27FC236}">
-                <a16:creationId xmlns:a16="http://schemas.microsoft.com/office/drawing/2014/main" id="{85CE2172-1F46-4463-BD4A-0E6056D41569}"/>
+                <a16:creationId xmlns:a16="http://schemas.microsoft.com/office/drawing/2014/main" id="{4C5463E9-6369-4667-AE2A-0A977B3965DA}"/>
               </a:ext>
             </a:extLst>
           </p:cNvPr>
@@ -6556,7 +6556,7 @@
           <p:cNvPr id="5" name="">
             <a:extLst xmlns:a="http://schemas.openxmlformats.org/drawingml/2006/main">
               <a:ext uri="{FF2B5EF4-FFF2-40B4-BE49-F238E27FC236}">
-                <a16:creationId xmlns:a16="http://schemas.microsoft.com/office/drawing/2014/main" id="{D406CD6D-A263-4874-87CB-0A601BF8F5D7}"/>
+                <a16:creationId xmlns:a16="http://schemas.microsoft.com/office/drawing/2014/main" id="{73F44717-1899-43C7-BBA7-47D245987FEB}"/>
               </a:ext>
             </a:extLst>
           </p:cNvPr>
@@ -6677,7 +6677,7 @@
           <p:cNvPr id="6" name="">
             <a:extLst xmlns:a="http://schemas.openxmlformats.org/drawingml/2006/main">
               <a:ext uri="{FF2B5EF4-FFF2-40B4-BE49-F238E27FC236}">
-                <a16:creationId xmlns:a16="http://schemas.microsoft.com/office/drawing/2014/main" id="{57C476E3-8E30-499F-AC96-96524EC54620}"/>
+                <a16:creationId xmlns:a16="http://schemas.microsoft.com/office/drawing/2014/main" id="{0E1634B8-2E4B-4535-9F1E-0B32BFEBF232}"/>
               </a:ext>
             </a:extLst>
           </p:cNvPr>
@@ -6798,7 +6798,7 @@
           <p:cNvPr id="7" name="">
             <a:extLst xmlns:a="http://schemas.openxmlformats.org/drawingml/2006/main">
               <a:ext uri="{FF2B5EF4-FFF2-40B4-BE49-F238E27FC236}">
-                <a16:creationId xmlns:a16="http://schemas.microsoft.com/office/drawing/2014/main" id="{60155632-5F17-476F-B4B5-0734243637F2}"/>
+                <a16:creationId xmlns:a16="http://schemas.microsoft.com/office/drawing/2014/main" id="{9FB1CC47-767C-4102-A9B6-A15127CC48BC}"/>
               </a:ext>
             </a:extLst>
           </p:cNvPr>
@@ -6919,7 +6919,7 @@
           <p:cNvPr id="8" name="">
             <a:extLst xmlns:a="http://schemas.openxmlformats.org/drawingml/2006/main">
               <a:ext uri="{FF2B5EF4-FFF2-40B4-BE49-F238E27FC236}">
-                <a16:creationId xmlns:a16="http://schemas.microsoft.com/office/drawing/2014/main" id="{B2067D61-0B37-4DDA-A217-C96271A377E2}"/>
+                <a16:creationId xmlns:a16="http://schemas.microsoft.com/office/drawing/2014/main" id="{ED38AAF7-8D69-46CE-9845-996C408ED696}"/>
               </a:ext>
             </a:extLst>
           </p:cNvPr>
@@ -6950,7 +6950,7 @@
           <p:cNvPr id="9" name="">
             <a:extLst xmlns:a="http://schemas.openxmlformats.org/drawingml/2006/main">
               <a:ext uri="{FF2B5EF4-FFF2-40B4-BE49-F238E27FC236}">
-                <a16:creationId xmlns:a16="http://schemas.microsoft.com/office/drawing/2014/main" id="{EC639A4D-E010-452A-9ED3-DE27819244E0}"/>
+                <a16:creationId xmlns:a16="http://schemas.microsoft.com/office/drawing/2014/main" id="{65C6791F-3B4D-456F-BF1B-C130B3040A21}"/>
               </a:ext>
             </a:extLst>
           </p:cNvPr>
@@ -7071,7 +7071,7 @@
           <p:cNvPr id="10" name="">
             <a:extLst xmlns:a="http://schemas.openxmlformats.org/drawingml/2006/main">
               <a:ext uri="{FF2B5EF4-FFF2-40B4-BE49-F238E27FC236}">
-                <a16:creationId xmlns:a16="http://schemas.microsoft.com/office/drawing/2014/main" id="{9072F47C-257E-4D57-8F55-A45E9664F3F8}"/>
+                <a16:creationId xmlns:a16="http://schemas.microsoft.com/office/drawing/2014/main" id="{2E692DFB-EEA9-4B57-89F1-BAC7B3C99F77}"/>
               </a:ext>
             </a:extLst>
           </p:cNvPr>
@@ -7190,7 +7190,7 @@
     </p:spTree>
     <p:extLst>
       <p:ext uri="{BB962C8B-B14F-4D97-AF65-F5344CB8AC3E}">
-        <p14:creationId xmlns:p14="http://schemas.microsoft.com/office/powerpoint/2010/main" val="1699845230"/>
+        <p14:creationId xmlns:p14="http://schemas.microsoft.com/office/powerpoint/2010/main" val="446165428"/>
       </p:ext>
     </p:extLst>
   </p:cSld>
@@ -7221,7 +7221,7 @@
           <p:cNvPr id="20" name="">
             <a:extLst xmlns:a="http://schemas.openxmlformats.org/drawingml/2006/main">
               <a:ext uri="{FF2B5EF4-FFF2-40B4-BE49-F238E27FC236}">
-                <a16:creationId xmlns:a16="http://schemas.microsoft.com/office/drawing/2014/main" id="{3B21BB4C-BDAB-49F6-A190-88C29EA6AE30}"/>
+                <a16:creationId xmlns:a16="http://schemas.microsoft.com/office/drawing/2014/main" id="{39C3FF23-F861-4307-9DFA-2DDCA544A7D2}"/>
               </a:ext>
             </a:extLst>
           </p:cNvPr>
@@ -7252,7 +7252,7 @@
           <p:cNvPr id="2" name="">
             <a:extLst xmlns:a="http://schemas.openxmlformats.org/drawingml/2006/main">
               <a:ext uri="{FF2B5EF4-FFF2-40B4-BE49-F238E27FC236}">
-                <a16:creationId xmlns:a16="http://schemas.microsoft.com/office/drawing/2014/main" id="{F504F654-BDBF-49CA-8A80-9BBC817BB489}"/>
+                <a16:creationId xmlns:a16="http://schemas.microsoft.com/office/drawing/2014/main" id="{A9D9B08F-6064-4F76-B986-9E273C7F52C6}"/>
               </a:ext>
             </a:extLst>
           </p:cNvPr>
@@ -7373,7 +7373,7 @@
           <p:cNvPr id="3" name="">
             <a:extLst xmlns:a="http://schemas.openxmlformats.org/drawingml/2006/main">
               <a:ext uri="{FF2B5EF4-FFF2-40B4-BE49-F238E27FC236}">
-                <a16:creationId xmlns:a16="http://schemas.microsoft.com/office/drawing/2014/main" id="{60A3008A-E80D-4057-86B9-0F627DC5EA93}"/>
+                <a16:creationId xmlns:a16="http://schemas.microsoft.com/office/drawing/2014/main" id="{15F11D21-5B01-45C2-8C12-0A5DB1FB6A8C}"/>
               </a:ext>
             </a:extLst>
           </p:cNvPr>
@@ -7494,7 +7494,7 @@
           <p:cNvPr id="4" name="">
             <a:extLst xmlns:a="http://schemas.openxmlformats.org/drawingml/2006/main">
               <a:ext uri="{FF2B5EF4-FFF2-40B4-BE49-F238E27FC236}">
-                <a16:creationId xmlns:a16="http://schemas.microsoft.com/office/drawing/2014/main" id="{9FBE471C-A199-4D61-B99B-995D1C70578E}"/>
+                <a16:creationId xmlns:a16="http://schemas.microsoft.com/office/drawing/2014/main" id="{08CFFD04-4EFF-4C8C-B4C9-76FE8B63C7BD}"/>
               </a:ext>
             </a:extLst>
           </p:cNvPr>
@@ -7615,7 +7615,7 @@
           <p:cNvPr id="5" name="">
             <a:extLst xmlns:a="http://schemas.openxmlformats.org/drawingml/2006/main">
               <a:ext uri="{FF2B5EF4-FFF2-40B4-BE49-F238E27FC236}">
-                <a16:creationId xmlns:a16="http://schemas.microsoft.com/office/drawing/2014/main" id="{DEF44A58-AC42-4666-BC00-E7D205687A35}"/>
+                <a16:creationId xmlns:a16="http://schemas.microsoft.com/office/drawing/2014/main" id="{C782E7EC-BA7F-4499-935C-83E035D03A0D}"/>
               </a:ext>
             </a:extLst>
           </p:cNvPr>
@@ -7646,7 +7646,7 @@
           <p:cNvPr id="6" name="">
             <a:extLst xmlns:a="http://schemas.openxmlformats.org/drawingml/2006/main">
               <a:ext uri="{FF2B5EF4-FFF2-40B4-BE49-F238E27FC236}">
-                <a16:creationId xmlns:a16="http://schemas.microsoft.com/office/drawing/2014/main" id="{FAE0438A-4B4C-43CE-9BE5-EFA0E0E4671E}"/>
+                <a16:creationId xmlns:a16="http://schemas.microsoft.com/office/drawing/2014/main" id="{4E1A4ADD-484F-4DD0-BAC4-7CCA22D93967}"/>
               </a:ext>
             </a:extLst>
           </p:cNvPr>
@@ -7767,7 +7767,7 @@
           <p:cNvPr id="7" name="">
             <a:extLst xmlns:a="http://schemas.openxmlformats.org/drawingml/2006/main">
               <a:ext uri="{FF2B5EF4-FFF2-40B4-BE49-F238E27FC236}">
-                <a16:creationId xmlns:a16="http://schemas.microsoft.com/office/drawing/2014/main" id="{6D3467A2-8B24-457B-8A5E-04428B5AC1E8}"/>
+                <a16:creationId xmlns:a16="http://schemas.microsoft.com/office/drawing/2014/main" id="{043D0BF0-4C66-4CB5-9008-2CB6AC5F8855}"/>
               </a:ext>
             </a:extLst>
           </p:cNvPr>
@@ -7888,7 +7888,7 @@
           <p:cNvPr id="8" name="">
             <a:extLst xmlns:a="http://schemas.openxmlformats.org/drawingml/2006/main">
               <a:ext uri="{FF2B5EF4-FFF2-40B4-BE49-F238E27FC236}">
-                <a16:creationId xmlns:a16="http://schemas.microsoft.com/office/drawing/2014/main" id="{B17B6C2A-1F52-43FB-A8EB-F1D0264E9BA6}"/>
+                <a16:creationId xmlns:a16="http://schemas.microsoft.com/office/drawing/2014/main" id="{74C0BBED-AC61-4101-A361-620719C92694}"/>
               </a:ext>
             </a:extLst>
           </p:cNvPr>
@@ -8009,7 +8009,7 @@
           <p:cNvPr id="9" name="">
             <a:extLst xmlns:a="http://schemas.openxmlformats.org/drawingml/2006/main">
               <a:ext uri="{FF2B5EF4-FFF2-40B4-BE49-F238E27FC236}">
-                <a16:creationId xmlns:a16="http://schemas.microsoft.com/office/drawing/2014/main" id="{5B90400D-B268-486D-84E7-ACBCBAAE9AA0}"/>
+                <a16:creationId xmlns:a16="http://schemas.microsoft.com/office/drawing/2014/main" id="{F20FCDE9-4B06-42F3-9E59-D464FD2A442A}"/>
               </a:ext>
             </a:extLst>
           </p:cNvPr>
@@ -8040,7 +8040,7 @@
           <p:cNvPr id="10" name="">
             <a:extLst xmlns:a="http://schemas.openxmlformats.org/drawingml/2006/main">
               <a:ext uri="{FF2B5EF4-FFF2-40B4-BE49-F238E27FC236}">
-                <a16:creationId xmlns:a16="http://schemas.microsoft.com/office/drawing/2014/main" id="{3D115A06-C1F6-4810-B772-DC34A2BE9A80}"/>
+                <a16:creationId xmlns:a16="http://schemas.microsoft.com/office/drawing/2014/main" id="{52955B84-C778-4ED1-B02E-DE630C05C60B}"/>
               </a:ext>
             </a:extLst>
           </p:cNvPr>
@@ -8161,7 +8161,7 @@
           <p:cNvPr id="11" name="">
             <a:extLst xmlns:a="http://schemas.openxmlformats.org/drawingml/2006/main">
               <a:ext uri="{FF2B5EF4-FFF2-40B4-BE49-F238E27FC236}">
-                <a16:creationId xmlns:a16="http://schemas.microsoft.com/office/drawing/2014/main" id="{EFC608A2-77DF-44C4-BC60-34003D2279DA}"/>
+                <a16:creationId xmlns:a16="http://schemas.microsoft.com/office/drawing/2014/main" id="{8EAAE6F9-10C0-4E62-9B7E-BB0AE0AB1001}"/>
               </a:ext>
             </a:extLst>
           </p:cNvPr>
@@ -8282,7 +8282,7 @@
           <p:cNvPr id="12" name="">
             <a:extLst xmlns:a="http://schemas.openxmlformats.org/drawingml/2006/main">
               <a:ext uri="{FF2B5EF4-FFF2-40B4-BE49-F238E27FC236}">
-                <a16:creationId xmlns:a16="http://schemas.microsoft.com/office/drawing/2014/main" id="{F42950E1-A2E7-4B62-A8BD-97B1AA4EF357}"/>
+                <a16:creationId xmlns:a16="http://schemas.microsoft.com/office/drawing/2014/main" id="{526896D6-4B31-4356-966C-CAC2E3C942F8}"/>
               </a:ext>
             </a:extLst>
           </p:cNvPr>
@@ -8403,7 +8403,7 @@
           <p:cNvPr id="13" name="">
             <a:extLst xmlns:a="http://schemas.openxmlformats.org/drawingml/2006/main">
               <a:ext uri="{FF2B5EF4-FFF2-40B4-BE49-F238E27FC236}">
-                <a16:creationId xmlns:a16="http://schemas.microsoft.com/office/drawing/2014/main" id="{6A28FD2A-6D91-4B51-974E-FEBCED867E85}"/>
+                <a16:creationId xmlns:a16="http://schemas.microsoft.com/office/drawing/2014/main" id="{94F5AE88-3B1B-4CF7-B696-D153A4B14A08}"/>
               </a:ext>
             </a:extLst>
           </p:cNvPr>
@@ -8434,7 +8434,7 @@
           <p:cNvPr id="14" name="">
             <a:extLst xmlns:a="http://schemas.openxmlformats.org/drawingml/2006/main">
               <a:ext uri="{FF2B5EF4-FFF2-40B4-BE49-F238E27FC236}">
-                <a16:creationId xmlns:a16="http://schemas.microsoft.com/office/drawing/2014/main" id="{396FC0EE-C1CB-479F-80FF-801FE2F22BAB}"/>
+                <a16:creationId xmlns:a16="http://schemas.microsoft.com/office/drawing/2014/main" id="{630AEE66-37A1-410D-B1E1-A3D0B471E0B4}"/>
               </a:ext>
             </a:extLst>
           </p:cNvPr>
@@ -8555,7 +8555,7 @@
           <p:cNvPr id="15" name="">
             <a:extLst xmlns:a="http://schemas.openxmlformats.org/drawingml/2006/main">
               <a:ext uri="{FF2B5EF4-FFF2-40B4-BE49-F238E27FC236}">
-                <a16:creationId xmlns:a16="http://schemas.microsoft.com/office/drawing/2014/main" id="{510AB16F-5810-4FA3-A395-A10BDE176A07}"/>
+                <a16:creationId xmlns:a16="http://schemas.microsoft.com/office/drawing/2014/main" id="{90DE80A0-52AE-42CE-BCE9-765B4AC3A222}"/>
               </a:ext>
             </a:extLst>
           </p:cNvPr>
@@ -8676,7 +8676,7 @@
           <p:cNvPr id="16" name="">
             <a:extLst xmlns:a="http://schemas.openxmlformats.org/drawingml/2006/main">
               <a:ext uri="{FF2B5EF4-FFF2-40B4-BE49-F238E27FC236}">
-                <a16:creationId xmlns:a16="http://schemas.microsoft.com/office/drawing/2014/main" id="{09839B62-6B4B-4624-A02C-F309609B783E}"/>
+                <a16:creationId xmlns:a16="http://schemas.microsoft.com/office/drawing/2014/main" id="{18BE4CF0-D73C-4144-AF36-A0EBA9249C33}"/>
               </a:ext>
             </a:extLst>
           </p:cNvPr>
@@ -8797,7 +8797,7 @@
           <p:cNvPr id="17" name="">
             <a:extLst xmlns:a="http://schemas.openxmlformats.org/drawingml/2006/main">
               <a:ext uri="{FF2B5EF4-FFF2-40B4-BE49-F238E27FC236}">
-                <a16:creationId xmlns:a16="http://schemas.microsoft.com/office/drawing/2014/main" id="{66BCD082-AD1C-44EE-BB45-DA12AC3A1703}"/>
+                <a16:creationId xmlns:a16="http://schemas.microsoft.com/office/drawing/2014/main" id="{2C2EA555-281A-4475-B2D4-CC6E0B98DD61}"/>
               </a:ext>
             </a:extLst>
           </p:cNvPr>
@@ -8828,7 +8828,7 @@
           <p:cNvPr id="18" name="">
             <a:extLst xmlns:a="http://schemas.openxmlformats.org/drawingml/2006/main">
               <a:ext uri="{FF2B5EF4-FFF2-40B4-BE49-F238E27FC236}">
-                <a16:creationId xmlns:a16="http://schemas.microsoft.com/office/drawing/2014/main" id="{DBC051D4-A409-48D2-8611-12B776E1174F}"/>
+                <a16:creationId xmlns:a16="http://schemas.microsoft.com/office/drawing/2014/main" id="{9D8B6A74-450D-46FC-8C18-FBBD4453A409}"/>
               </a:ext>
             </a:extLst>
           </p:cNvPr>
@@ -8949,7 +8949,7 @@
           <p:cNvPr id="19" name="">
             <a:extLst xmlns:a="http://schemas.openxmlformats.org/drawingml/2006/main">
               <a:ext uri="{FF2B5EF4-FFF2-40B4-BE49-F238E27FC236}">
-                <a16:creationId xmlns:a16="http://schemas.microsoft.com/office/drawing/2014/main" id="{679AA8A2-A945-4FA1-95D9-334FBDCF588A}"/>
+                <a16:creationId xmlns:a16="http://schemas.microsoft.com/office/drawing/2014/main" id="{8736245E-B849-4551-805D-C8D7556D6679}"/>
               </a:ext>
             </a:extLst>
           </p:cNvPr>
@@ -9068,7 +9068,7 @@
     </p:spTree>
     <p:extLst>
       <p:ext uri="{BB962C8B-B14F-4D97-AF65-F5344CB8AC3E}">
-        <p14:creationId xmlns:p14="http://schemas.microsoft.com/office/powerpoint/2010/main" val="1068304538"/>
+        <p14:creationId xmlns:p14="http://schemas.microsoft.com/office/powerpoint/2010/main" val="1224494688"/>
       </p:ext>
     </p:extLst>
   </p:cSld>
@@ -9099,7 +9099,7 @@
           <p:cNvPr id="11" name="">
             <a:extLst xmlns:a="http://schemas.openxmlformats.org/drawingml/2006/main">
               <a:ext uri="{FF2B5EF4-FFF2-40B4-BE49-F238E27FC236}">
-                <a16:creationId xmlns:a16="http://schemas.microsoft.com/office/drawing/2014/main" id="{741D3B04-D702-4BED-AFEC-8E04EA8C788F}"/>
+                <a16:creationId xmlns:a16="http://schemas.microsoft.com/office/drawing/2014/main" id="{480FA3A6-3E91-47CF-BD96-8B13A9F1AEEB}"/>
               </a:ext>
             </a:extLst>
           </p:cNvPr>
@@ -9130,7 +9130,7 @@
           <p:cNvPr id="2" name="">
             <a:extLst xmlns:a="http://schemas.openxmlformats.org/drawingml/2006/main">
               <a:ext uri="{FF2B5EF4-FFF2-40B4-BE49-F238E27FC236}">
-                <a16:creationId xmlns:a16="http://schemas.microsoft.com/office/drawing/2014/main" id="{01A803EE-C7B6-4084-BB2D-61E58E902E5D}"/>
+                <a16:creationId xmlns:a16="http://schemas.microsoft.com/office/drawing/2014/main" id="{6BED8C65-6E68-4B55-8B97-DB937C9FFFE1}"/>
               </a:ext>
             </a:extLst>
           </p:cNvPr>
@@ -9251,7 +9251,7 @@
           <p:cNvPr id="3" name="">
             <a:extLst xmlns:a="http://schemas.openxmlformats.org/drawingml/2006/main">
               <a:ext uri="{FF2B5EF4-FFF2-40B4-BE49-F238E27FC236}">
-                <a16:creationId xmlns:a16="http://schemas.microsoft.com/office/drawing/2014/main" id="{B0938C2B-C510-4946-9413-F3B23D95E8CC}"/>
+                <a16:creationId xmlns:a16="http://schemas.microsoft.com/office/drawing/2014/main" id="{48CBCCB0-31C2-48B0-ABBF-80C904E2487A}"/>
               </a:ext>
             </a:extLst>
           </p:cNvPr>
@@ -9372,7 +9372,7 @@
           <p:cNvPr id="4" name="">
             <a:extLst xmlns:a="http://schemas.openxmlformats.org/drawingml/2006/main">
               <a:ext uri="{FF2B5EF4-FFF2-40B4-BE49-F238E27FC236}">
-                <a16:creationId xmlns:a16="http://schemas.microsoft.com/office/drawing/2014/main" id="{00F9C01E-F9E8-4B5D-AE6C-BE19591D67E7}"/>
+                <a16:creationId xmlns:a16="http://schemas.microsoft.com/office/drawing/2014/main" id="{9572158B-FA79-4341-A181-5B5AEBCF6347}"/>
               </a:ext>
             </a:extLst>
           </p:cNvPr>
@@ -9493,7 +9493,7 @@
           <p:cNvPr id="5" name="">
             <a:extLst xmlns:a="http://schemas.openxmlformats.org/drawingml/2006/main">
               <a:ext uri="{FF2B5EF4-FFF2-40B4-BE49-F238E27FC236}">
-                <a16:creationId xmlns:a16="http://schemas.microsoft.com/office/drawing/2014/main" id="{919D8694-EC09-4A3F-B1C8-D3703C66EEF2}"/>
+                <a16:creationId xmlns:a16="http://schemas.microsoft.com/office/drawing/2014/main" id="{FF600589-2C31-4D99-A376-092D9B9047E5}"/>
               </a:ext>
             </a:extLst>
           </p:cNvPr>
@@ -9648,7 +9648,7 @@
           <p:cNvPr id="6" name="">
             <a:extLst xmlns:a="http://schemas.openxmlformats.org/drawingml/2006/main">
               <a:ext uri="{FF2B5EF4-FFF2-40B4-BE49-F238E27FC236}">
-                <a16:creationId xmlns:a16="http://schemas.microsoft.com/office/drawing/2014/main" id="{B30EBAF8-BAE4-4777-B2C9-C96094CEE824}"/>
+                <a16:creationId xmlns:a16="http://schemas.microsoft.com/office/drawing/2014/main" id="{42F44DF2-2692-4BEC-94FB-3A805AB67566}"/>
               </a:ext>
             </a:extLst>
           </p:cNvPr>
@@ -9679,7 +9679,7 @@
           <p:cNvPr id="7" name="">
             <a:extLst xmlns:a="http://schemas.openxmlformats.org/drawingml/2006/main">
               <a:ext uri="{FF2B5EF4-FFF2-40B4-BE49-F238E27FC236}">
-                <a16:creationId xmlns:a16="http://schemas.microsoft.com/office/drawing/2014/main" id="{7A92AA5B-5D83-4B5F-8491-7FFFBE578E51}"/>
+                <a16:creationId xmlns:a16="http://schemas.microsoft.com/office/drawing/2014/main" id="{7254DDE2-BEF0-41B1-9D9C-069F126CB128}"/>
               </a:ext>
             </a:extLst>
           </p:cNvPr>
@@ -9800,7 +9800,7 @@
           <p:cNvPr id="8" name="">
             <a:extLst xmlns:a="http://schemas.openxmlformats.org/drawingml/2006/main">
               <a:ext uri="{FF2B5EF4-FFF2-40B4-BE49-F238E27FC236}">
-                <a16:creationId xmlns:a16="http://schemas.microsoft.com/office/drawing/2014/main" id="{E6BCFBCC-FD41-4D3B-933F-5B6199C750FB}"/>
+                <a16:creationId xmlns:a16="http://schemas.microsoft.com/office/drawing/2014/main" id="{1DC81EF5-9D0E-405D-AA32-1A4E5A6EC78E}"/>
               </a:ext>
             </a:extLst>
           </p:cNvPr>
@@ -9955,7 +9955,7 @@
           <p:cNvPr id="9" name="">
             <a:extLst xmlns:a="http://schemas.openxmlformats.org/drawingml/2006/main">
               <a:ext uri="{FF2B5EF4-FFF2-40B4-BE49-F238E27FC236}">
-                <a16:creationId xmlns:a16="http://schemas.microsoft.com/office/drawing/2014/main" id="{22B0B62D-8D38-45E7-9738-4D2CB74ABBE7}"/>
+                <a16:creationId xmlns:a16="http://schemas.microsoft.com/office/drawing/2014/main" id="{10F8629B-B3B2-4080-9A2B-B9B0FD82DF8F}"/>
               </a:ext>
             </a:extLst>
           </p:cNvPr>
@@ -9986,7 +9986,7 @@
           <p:cNvPr id="10" name="">
             <a:extLst xmlns:a="http://schemas.openxmlformats.org/drawingml/2006/main">
               <a:ext uri="{FF2B5EF4-FFF2-40B4-BE49-F238E27FC236}">
-                <a16:creationId xmlns:a16="http://schemas.microsoft.com/office/drawing/2014/main" id="{70A00160-275A-4B1A-AAED-C08774465A3B}"/>
+                <a16:creationId xmlns:a16="http://schemas.microsoft.com/office/drawing/2014/main" id="{9D341FD1-3629-4168-89C9-DA9BD74285EA}"/>
               </a:ext>
             </a:extLst>
           </p:cNvPr>
@@ -10105,7 +10105,7 @@
     </p:spTree>
     <p:extLst>
       <p:ext uri="{BB962C8B-B14F-4D97-AF65-F5344CB8AC3E}">
-        <p14:creationId xmlns:p14="http://schemas.microsoft.com/office/powerpoint/2010/main" val="598798834"/>
+        <p14:creationId xmlns:p14="http://schemas.microsoft.com/office/powerpoint/2010/main" val="2039119958"/>
       </p:ext>
     </p:extLst>
   </p:cSld>
@@ -10136,7 +10136,7 @@
           <p:cNvPr id="10" name="">
             <a:extLst xmlns:a="http://schemas.openxmlformats.org/drawingml/2006/main">
               <a:ext uri="{FF2B5EF4-FFF2-40B4-BE49-F238E27FC236}">
-                <a16:creationId xmlns:a16="http://schemas.microsoft.com/office/drawing/2014/main" id="{198C1B22-DAC1-4DE2-91FE-0EEA0505783F}"/>
+                <a16:creationId xmlns:a16="http://schemas.microsoft.com/office/drawing/2014/main" id="{71C5B5B3-5972-43A1-9D56-7DACBD14A86A}"/>
               </a:ext>
             </a:extLst>
           </p:cNvPr>
@@ -10167,7 +10167,7 @@
           <p:cNvPr id="2" name="">
             <a:extLst xmlns:a="http://schemas.openxmlformats.org/drawingml/2006/main">
               <a:ext uri="{FF2B5EF4-FFF2-40B4-BE49-F238E27FC236}">
-                <a16:creationId xmlns:a16="http://schemas.microsoft.com/office/drawing/2014/main" id="{F7344BD1-E923-4BB3-AACC-6F6A920EA300}"/>
+                <a16:creationId xmlns:a16="http://schemas.microsoft.com/office/drawing/2014/main" id="{33C445E8-3CBA-469B-B045-3B535D26EF8B}"/>
               </a:ext>
             </a:extLst>
           </p:cNvPr>
@@ -10288,7 +10288,7 @@
           <p:cNvPr id="3" name="">
             <a:extLst xmlns:a="http://schemas.openxmlformats.org/drawingml/2006/main">
               <a:ext uri="{FF2B5EF4-FFF2-40B4-BE49-F238E27FC236}">
-                <a16:creationId xmlns:a16="http://schemas.microsoft.com/office/drawing/2014/main" id="{2241AC4C-BD53-45F6-9C8F-BEB7C57CDA8A}"/>
+                <a16:creationId xmlns:a16="http://schemas.microsoft.com/office/drawing/2014/main" id="{7CB2765A-81D2-4CFE-8C4C-00EA9043F927}"/>
               </a:ext>
             </a:extLst>
           </p:cNvPr>
@@ -10409,7 +10409,7 @@
           <p:cNvPr id="4" name="">
             <a:extLst xmlns:a="http://schemas.openxmlformats.org/drawingml/2006/main">
               <a:ext uri="{FF2B5EF4-FFF2-40B4-BE49-F238E27FC236}">
-                <a16:creationId xmlns:a16="http://schemas.microsoft.com/office/drawing/2014/main" id="{D84AFBC2-298B-419D-A8F1-ED4F76801D3D}"/>
+                <a16:creationId xmlns:a16="http://schemas.microsoft.com/office/drawing/2014/main" id="{931FAED0-45AA-4157-9326-DC559759C391}"/>
               </a:ext>
             </a:extLst>
           </p:cNvPr>
@@ -10520,7 +10520,7 @@
                   <a:srgbClr val="277A53"/>
                 </a:solidFill>
               </a:rPr>
-              <a:t>4 → 13</a:t>
+              <a:t>13 → 23</a:t>
             </a:r>
           </a:p>
         </p:txBody>
@@ -10530,7 +10530,7 @@
           <p:cNvPr id="5" name="">
             <a:extLst xmlns:a="http://schemas.openxmlformats.org/drawingml/2006/main">
               <a:ext uri="{FF2B5EF4-FFF2-40B4-BE49-F238E27FC236}">
-                <a16:creationId xmlns:a16="http://schemas.microsoft.com/office/drawing/2014/main" id="{9A72F5CE-8943-469E-9728-EEBEAE62A445}"/>
+                <a16:creationId xmlns:a16="http://schemas.microsoft.com/office/drawing/2014/main" id="{32FF78A3-EB4A-4B09-929D-92955DE32345}"/>
               </a:ext>
             </a:extLst>
           </p:cNvPr>
@@ -10641,7 +10641,7 @@
                   <a:srgbClr val="17251F"/>
                 </a:solidFill>
               </a:rPr>
-              <a:t>lecturas registradas durante una sesión de simulación</a:t>
+              <a:t>lecturas acumuladas en AWS tras reanudar Wokwi</a:t>
             </a:r>
           </a:p>
         </p:txBody>
@@ -10651,7 +10651,7 @@
           <p:cNvPr id="6" name="">
             <a:extLst xmlns:a="http://schemas.openxmlformats.org/drawingml/2006/main">
               <a:ext uri="{FF2B5EF4-FFF2-40B4-BE49-F238E27FC236}">
-                <a16:creationId xmlns:a16="http://schemas.microsoft.com/office/drawing/2014/main" id="{76FD2FCC-3565-4F2A-AC34-13036C7B4D96}"/>
+                <a16:creationId xmlns:a16="http://schemas.microsoft.com/office/drawing/2014/main" id="{0EEE6EE4-C83C-45FA-859F-F21975D207F6}"/>
               </a:ext>
             </a:extLst>
           </p:cNvPr>
@@ -10762,7 +10762,7 @@
                   <a:srgbClr val="173B30"/>
                 </a:solidFill>
               </a:rPr>
-              <a:t>23 · 24 · 25</a:t>
+              <a:t>23 · 24</a:t>
             </a:r>
           </a:p>
         </p:txBody>
@@ -10772,7 +10772,7 @@
           <p:cNvPr id="7" name="">
             <a:extLst xmlns:a="http://schemas.openxmlformats.org/drawingml/2006/main">
               <a:ext uri="{FF2B5EF4-FFF2-40B4-BE49-F238E27FC236}">
-                <a16:creationId xmlns:a16="http://schemas.microsoft.com/office/drawing/2014/main" id="{8C260434-AFD5-45C2-BAEA-60F331DBF346}"/>
+                <a16:creationId xmlns:a16="http://schemas.microsoft.com/office/drawing/2014/main" id="{3916786C-9367-4F06-89A6-297293BC8907}"/>
               </a:ext>
             </a:extLst>
           </p:cNvPr>
@@ -10883,7 +10883,7 @@
                   <a:srgbClr val="17251F"/>
                 </a:solidFill>
               </a:rPr>
-              <a:t>secuencias del mismo arranque vistas en la API y el CSV</a:t>
+              <a:t>mismo arranque confirmado en Ubuntu local y AWS</a:t>
             </a:r>
           </a:p>
         </p:txBody>
@@ -10893,7 +10893,7 @@
           <p:cNvPr id="8" name="">
             <a:extLst xmlns:a="http://schemas.openxmlformats.org/drawingml/2006/main">
               <a:ext uri="{FF2B5EF4-FFF2-40B4-BE49-F238E27FC236}">
-                <a16:creationId xmlns:a16="http://schemas.microsoft.com/office/drawing/2014/main" id="{C607261D-3D98-4C8A-B6C5-FC62BAEA270A}"/>
+                <a16:creationId xmlns:a16="http://schemas.microsoft.com/office/drawing/2014/main" id="{0199C75C-92B4-4212-BD9C-893F34EEB145}"/>
               </a:ext>
             </a:extLst>
           </p:cNvPr>
@@ -10924,7 +10924,7 @@
           <p:cNvPr id="9" name="">
             <a:extLst xmlns:a="http://schemas.openxmlformats.org/drawingml/2006/main">
               <a:ext uri="{FF2B5EF4-FFF2-40B4-BE49-F238E27FC236}">
-                <a16:creationId xmlns:a16="http://schemas.microsoft.com/office/drawing/2014/main" id="{89C602D9-02B1-431B-8619-6711CC6A6B1F}"/>
+                <a16:creationId xmlns:a16="http://schemas.microsoft.com/office/drawing/2014/main" id="{B7BE3A38-3863-4207-A857-EE84060E7016}"/>
               </a:ext>
             </a:extLst>
           </p:cNvPr>
@@ -11043,7 +11043,7 @@
     </p:spTree>
     <p:extLst>
       <p:ext uri="{BB962C8B-B14F-4D97-AF65-F5344CB8AC3E}">
-        <p14:creationId xmlns:p14="http://schemas.microsoft.com/office/powerpoint/2010/main" val="493685250"/>
+        <p14:creationId xmlns:p14="http://schemas.microsoft.com/office/powerpoint/2010/main" val="261666685"/>
       </p:ext>
     </p:extLst>
   </p:cSld>
@@ -11074,7 +11074,7 @@
           <p:cNvPr id="8" name="">
             <a:extLst xmlns:a="http://schemas.openxmlformats.org/drawingml/2006/main">
               <a:ext uri="{FF2B5EF4-FFF2-40B4-BE49-F238E27FC236}">
-                <a16:creationId xmlns:a16="http://schemas.microsoft.com/office/drawing/2014/main" id="{D0BF0221-E7B1-46B2-A8DA-37AE5C0D88C2}"/>
+                <a16:creationId xmlns:a16="http://schemas.microsoft.com/office/drawing/2014/main" id="{EA7944B0-3315-4044-AD31-6B1CF18836BB}"/>
               </a:ext>
             </a:extLst>
           </p:cNvPr>
@@ -11105,7 +11105,7 @@
           <p:cNvPr id="2" name="">
             <a:extLst xmlns:a="http://schemas.openxmlformats.org/drawingml/2006/main">
               <a:ext uri="{FF2B5EF4-FFF2-40B4-BE49-F238E27FC236}">
-                <a16:creationId xmlns:a16="http://schemas.microsoft.com/office/drawing/2014/main" id="{A6595552-0EDD-43F7-9EF5-675157D36D4A}"/>
+                <a16:creationId xmlns:a16="http://schemas.microsoft.com/office/drawing/2014/main" id="{3737B98D-21D6-49B1-9C3E-017C49CBCB8F}"/>
               </a:ext>
             </a:extLst>
           </p:cNvPr>
@@ -11216,7 +11216,7 @@
                   <a:srgbClr val="173B30"/>
                 </a:solidFill>
               </a:rPr>
-              <a:t>Alcance de la demostración</a:t>
+              <a:t>Dos entornos comprobados</a:t>
             </a:r>
           </a:p>
         </p:txBody>
@@ -11226,7 +11226,7 @@
           <p:cNvPr id="3" name="">
             <a:extLst xmlns:a="http://schemas.openxmlformats.org/drawingml/2006/main">
               <a:ext uri="{FF2B5EF4-FFF2-40B4-BE49-F238E27FC236}">
-                <a16:creationId xmlns:a16="http://schemas.microsoft.com/office/drawing/2014/main" id="{F329313A-BD9B-47BD-AD4F-E696C7E8B197}"/>
+                <a16:creationId xmlns:a16="http://schemas.microsoft.com/office/drawing/2014/main" id="{6C28054D-228E-4A52-B8A0-554ACCD4B008}"/>
               </a:ext>
             </a:extLst>
           </p:cNvPr>
@@ -11347,7 +11347,7 @@
           <p:cNvPr id="4" name="">
             <a:extLst xmlns:a="http://schemas.openxmlformats.org/drawingml/2006/main">
               <a:ext uri="{FF2B5EF4-FFF2-40B4-BE49-F238E27FC236}">
-                <a16:creationId xmlns:a16="http://schemas.microsoft.com/office/drawing/2014/main" id="{67551A2C-499A-432C-AAF5-B0352D3B4E5E}"/>
+                <a16:creationId xmlns:a16="http://schemas.microsoft.com/office/drawing/2014/main" id="{299A4A5F-A34C-410C-BF36-8CE938C77F4D}"/>
               </a:ext>
             </a:extLst>
           </p:cNvPr>
@@ -11359,7 +11359,7 @@
         <p:spPr>
           <a:xfrm xmlns:a="http://schemas.openxmlformats.org/drawingml/2006/main">
             <a:off x="742950" y="1714500"/>
-            <a:ext cx="10572750" cy="600075"/>
+            <a:ext cx="10572750" cy="952500"/>
           </a:xfrm>
           <a:prstGeom xmlns:a="http://schemas.openxmlformats.org/drawingml/2006/main" prst="rect">
             <a:avLst/>
@@ -11458,7 +11458,7 @@
                   <a:srgbClr val="173B30"/>
                 </a:solidFill>
               </a:rPr>
-              <a:t>La prueba en AWS corresponde a una sesión observada.</a:t>
+              <a:t>Ubuntu local y AWS recibieron lecturas del mismo ESP32 simulado.</a:t>
             </a:r>
           </a:p>
         </p:txBody>
@@ -11468,7 +11468,7 @@
           <p:cNvPr id="5" name="">
             <a:extLst xmlns:a="http://schemas.openxmlformats.org/drawingml/2006/main">
               <a:ext uri="{FF2B5EF4-FFF2-40B4-BE49-F238E27FC236}">
-                <a16:creationId xmlns:a16="http://schemas.microsoft.com/office/drawing/2014/main" id="{14FB39D1-27BD-4256-9B9D-ECC8DD214846}"/>
+                <a16:creationId xmlns:a16="http://schemas.microsoft.com/office/drawing/2014/main" id="{DE92A823-451D-4571-B042-47496F26B92F}"/>
               </a:ext>
             </a:extLst>
           </p:cNvPr>
@@ -11479,8 +11479,8 @@
         </p:nvSpPr>
         <p:spPr>
           <a:xfrm xmlns:a="http://schemas.openxmlformats.org/drawingml/2006/main">
-            <a:off x="742950" y="2571750"/>
-            <a:ext cx="10382250" cy="1047750"/>
+            <a:off x="742950" y="2857500"/>
+            <a:ext cx="10382250" cy="1000125"/>
           </a:xfrm>
           <a:prstGeom xmlns:a="http://schemas.openxmlformats.org/drawingml/2006/main" prst="rect">
             <a:avLst/>
@@ -11579,7 +11579,7 @@
                   <a:srgbClr val="17251F"/>
                 </a:solidFill>
               </a:rPr>
-              <a:t>En una comprobación posterior, la pasarela Wi-Fi de Wokwi no conectó. El ESP32 mantuvo el control local, pero no llegaron nuevas lecturas al servidor.</a:t>
+              <a:t>En Ubuntu local, las secuencias 22–25 quedaron en SQLite y CSV. En AWS, las secuencias 23 y 24 aparecen en PostgreSQL y CSV.</a:t>
             </a:r>
           </a:p>
         </p:txBody>
@@ -11589,7 +11589,7 @@
           <p:cNvPr id="6" name="">
             <a:extLst xmlns:a="http://schemas.openxmlformats.org/drawingml/2006/main">
               <a:ext uri="{FF2B5EF4-FFF2-40B4-BE49-F238E27FC236}">
-                <a16:creationId xmlns:a16="http://schemas.microsoft.com/office/drawing/2014/main" id="{26A54074-658F-41C5-B986-1FACED75CBDA}"/>
+                <a16:creationId xmlns:a16="http://schemas.microsoft.com/office/drawing/2014/main" id="{6872C485-FFBF-427C-9762-791D3D0AE9B0}"/>
               </a:ext>
             </a:extLst>
           </p:cNvPr>
@@ -11620,7 +11620,7 @@
           <p:cNvPr id="7" name="">
             <a:extLst xmlns:a="http://schemas.openxmlformats.org/drawingml/2006/main">
               <a:ext uri="{FF2B5EF4-FFF2-40B4-BE49-F238E27FC236}">
-                <a16:creationId xmlns:a16="http://schemas.microsoft.com/office/drawing/2014/main" id="{D335DE93-4F4E-481F-8EDB-AAD4C49FF8CC}"/>
+                <a16:creationId xmlns:a16="http://schemas.microsoft.com/office/drawing/2014/main" id="{2D94F976-1FA3-4113-A30D-BA49400D1DA2}"/>
               </a:ext>
             </a:extLst>
           </p:cNvPr>
@@ -11731,7 +11731,7 @@
                   <a:srgbClr val="4C6357"/>
                 </a:solidFill>
               </a:rPr>
-              <a:t>Los datos son simulados. El broker MQTT es público. El servidor AWS usa HTTP. La guía del repositorio describe por separado cómo reproducir la etapa Ubuntu local.</a:t>
+              <a:t>La conexión Wi-Fi de Wokwi falló durante una prueba anterior y después se recuperó. Los datos son simulados, el broker MQTT es público y el servidor AWS usa HTTP.</a:t>
             </a:r>
           </a:p>
         </p:txBody>
@@ -11739,7 +11739,7 @@
     </p:spTree>
     <p:extLst>
       <p:ext uri="{BB962C8B-B14F-4D97-AF65-F5344CB8AC3E}">
-        <p14:creationId xmlns:p14="http://schemas.microsoft.com/office/powerpoint/2010/main" val="1698029239"/>
+        <p14:creationId xmlns:p14="http://schemas.microsoft.com/office/powerpoint/2010/main" val="734815675"/>
       </p:ext>
     </p:extLst>
   </p:cSld>
@@ -11770,7 +11770,7 @@
           <p:cNvPr id="10" name="">
             <a:extLst xmlns:a="http://schemas.openxmlformats.org/drawingml/2006/main">
               <a:ext uri="{FF2B5EF4-FFF2-40B4-BE49-F238E27FC236}">
-                <a16:creationId xmlns:a16="http://schemas.microsoft.com/office/drawing/2014/main" id="{D8C859C7-479D-4880-B59B-59C11D2AC308}"/>
+                <a16:creationId xmlns:a16="http://schemas.microsoft.com/office/drawing/2014/main" id="{7652C208-EC1E-4D99-A0DC-728E3A2CEFCF}"/>
               </a:ext>
             </a:extLst>
           </p:cNvPr>
@@ -11801,7 +11801,7 @@
           <p:cNvPr id="2" name="">
             <a:extLst xmlns:a="http://schemas.openxmlformats.org/drawingml/2006/main">
               <a:ext uri="{FF2B5EF4-FFF2-40B4-BE49-F238E27FC236}">
-                <a16:creationId xmlns:a16="http://schemas.microsoft.com/office/drawing/2014/main" id="{CEAD9BFF-95E3-43C3-8637-A472B0A3194A}"/>
+                <a16:creationId xmlns:a16="http://schemas.microsoft.com/office/drawing/2014/main" id="{ED867BFC-A495-4779-88AA-A08C0A5A1436}"/>
               </a:ext>
             </a:extLst>
           </p:cNvPr>
@@ -11922,7 +11922,7 @@
           <p:cNvPr id="3" name="">
             <a:extLst xmlns:a="http://schemas.openxmlformats.org/drawingml/2006/main">
               <a:ext uri="{FF2B5EF4-FFF2-40B4-BE49-F238E27FC236}">
-                <a16:creationId xmlns:a16="http://schemas.microsoft.com/office/drawing/2014/main" id="{29901644-E11A-40DE-A2EE-E882457FE903}"/>
+                <a16:creationId xmlns:a16="http://schemas.microsoft.com/office/drawing/2014/main" id="{405EAA4F-D527-4C3E-B704-03FD54A9E4B3}"/>
               </a:ext>
             </a:extLst>
           </p:cNvPr>
@@ -12043,7 +12043,7 @@
           <p:cNvPr id="4" name="">
             <a:extLst xmlns:a="http://schemas.openxmlformats.org/drawingml/2006/main">
               <a:ext uri="{FF2B5EF4-FFF2-40B4-BE49-F238E27FC236}">
-                <a16:creationId xmlns:a16="http://schemas.microsoft.com/office/drawing/2014/main" id="{0CCC8564-7581-42D1-B0F7-B840AF58B8E1}"/>
+                <a16:creationId xmlns:a16="http://schemas.microsoft.com/office/drawing/2014/main" id="{513DAA05-8B7A-44BA-8EFC-369D0B26383C}"/>
               </a:ext>
             </a:extLst>
           </p:cNvPr>
@@ -12164,7 +12164,7 @@
           <p:cNvPr id="5" name="">
             <a:extLst xmlns:a="http://schemas.openxmlformats.org/drawingml/2006/main">
               <a:ext uri="{FF2B5EF4-FFF2-40B4-BE49-F238E27FC236}">
-                <a16:creationId xmlns:a16="http://schemas.microsoft.com/office/drawing/2014/main" id="{02F6B5B9-5565-45C6-9C6C-D1BD8F3C7740}"/>
+                <a16:creationId xmlns:a16="http://schemas.microsoft.com/office/drawing/2014/main" id="{D23A91BC-79A8-4A6E-A60B-993464054CAF}"/>
               </a:ext>
             </a:extLst>
           </p:cNvPr>
@@ -12285,7 +12285,7 @@
           <p:cNvPr id="6" name="">
             <a:extLst xmlns:a="http://schemas.openxmlformats.org/drawingml/2006/main">
               <a:ext uri="{FF2B5EF4-FFF2-40B4-BE49-F238E27FC236}">
-                <a16:creationId xmlns:a16="http://schemas.microsoft.com/office/drawing/2014/main" id="{1AB83825-0536-4C6F-9545-C1F6823CE299}"/>
+                <a16:creationId xmlns:a16="http://schemas.microsoft.com/office/drawing/2014/main" id="{4CB9FDC0-79D6-412E-A3AF-7A94DEB4FAE1}"/>
               </a:ext>
             </a:extLst>
           </p:cNvPr>
@@ -12406,7 +12406,7 @@
           <p:cNvPr id="7" name="">
             <a:extLst xmlns:a="http://schemas.openxmlformats.org/drawingml/2006/main">
               <a:ext uri="{FF2B5EF4-FFF2-40B4-BE49-F238E27FC236}">
-                <a16:creationId xmlns:a16="http://schemas.microsoft.com/office/drawing/2014/main" id="{BDB86E7C-96A9-4E31-98F8-A1BE5C5EE2D1}"/>
+                <a16:creationId xmlns:a16="http://schemas.microsoft.com/office/drawing/2014/main" id="{678AC7B9-2F1A-4F12-9911-DAAB9DB945AB}"/>
               </a:ext>
             </a:extLst>
           </p:cNvPr>
@@ -12517,7 +12517,7 @@
                   <a:srgbClr val="17251F"/>
                 </a:solidFill>
               </a:rPr>
-              <a:t>4. Comparar la misma secuencia en API, PostgreSQL y CSV.</a:t>
+              <a:t>4. Comparar una secuencia en Ubuntu local y AWS, con DB y CSV.</a:t>
             </a:r>
           </a:p>
         </p:txBody>
@@ -12527,7 +12527,7 @@
           <p:cNvPr id="8" name="">
             <a:extLst xmlns:a="http://schemas.openxmlformats.org/drawingml/2006/main">
               <a:ext uri="{FF2B5EF4-FFF2-40B4-BE49-F238E27FC236}">
-                <a16:creationId xmlns:a16="http://schemas.microsoft.com/office/drawing/2014/main" id="{57A7A0BE-7E4E-44EB-A800-D8C597C6256A}"/>
+                <a16:creationId xmlns:a16="http://schemas.microsoft.com/office/drawing/2014/main" id="{F9A1800C-EA03-4E29-973B-5BDDED5F23DE}"/>
               </a:ext>
             </a:extLst>
           </p:cNvPr>
@@ -12648,7 +12648,7 @@
           <p:cNvPr id="9" name="">
             <a:extLst xmlns:a="http://schemas.openxmlformats.org/drawingml/2006/main">
               <a:ext uri="{FF2B5EF4-FFF2-40B4-BE49-F238E27FC236}">
-                <a16:creationId xmlns:a16="http://schemas.microsoft.com/office/drawing/2014/main" id="{B40EBB5A-663D-4329-9992-1FAEF57667AB}"/>
+                <a16:creationId xmlns:a16="http://schemas.microsoft.com/office/drawing/2014/main" id="{FAAF686C-7AF9-4DF1-8087-D275C9DFFB2F}"/>
               </a:ext>
             </a:extLst>
           </p:cNvPr>
@@ -12767,7 +12767,7 @@
     </p:spTree>
     <p:extLst>
       <p:ext uri="{BB962C8B-B14F-4D97-AF65-F5344CB8AC3E}">
-        <p14:creationId xmlns:p14="http://schemas.microsoft.com/office/powerpoint/2010/main" val="1934947349"/>
+        <p14:creationId xmlns:p14="http://schemas.microsoft.com/office/powerpoint/2010/main" val="1755635097"/>
       </p:ext>
     </p:extLst>
   </p:cSld>

</xml_diff>